<commit_message>
Update Inhaltsverzeichnis to 9 themes and adjust slide counters
- TOC slide rebuilt as 3x3 grid showing all 9 themes including the
  three newly added ones (KI-Funktionsweise, Chancen & Risiken,
  Ausblick).
- Added subtitle "9 Themen · ca. 12-14 Minuten" under the heading.
- Updated every "Folie X / 6" marker to "Folie X / 9" so the slide
  counters in the headers match the new agenda.

https://claude.ai/code/session_01MdzJJUoHUKeykvjoVMaxnm
</commit_message>
<xml_diff>
--- a/output/KI_Steuerhinterziehung_NEU.pptx
+++ b/output/KI_Steuerhinterziehung_NEU.pptx
@@ -3614,7 +3614,7 @@
                 </a:solidFill>
                 <a:latin typeface="Calibri"/>
               </a:rPr>
-              <a:t>Folie 5 / 6</a:t>
+              <a:t>Folie 5 / 9</a:t>
             </a:r>
           </a:p>
         </p:txBody>
@@ -4191,7 +4191,7 @@
                 </a:solidFill>
                 <a:latin typeface="Calibri"/>
               </a:rPr>
-              <a:t>Folie 5 / 6</a:t>
+              <a:t>Folie 5 / 9</a:t>
             </a:r>
           </a:p>
         </p:txBody>
@@ -4733,7 +4733,7 @@
                 </a:solidFill>
                 <a:latin typeface="Calibri"/>
               </a:rPr>
-              <a:t>Folie 6 / 6</a:t>
+              <a:t>Folie 6 / 9</a:t>
             </a:r>
           </a:p>
         </p:txBody>
@@ -5389,7 +5389,7 @@
                 </a:solidFill>
                 <a:latin typeface="Calibri"/>
               </a:rPr>
-              <a:t>Folie 6 / 6</a:t>
+              <a:t>Folie 6 / 9</a:t>
             </a:r>
           </a:p>
         </p:txBody>
@@ -6045,7 +6045,7 @@
                 </a:solidFill>
                 <a:latin typeface="Calibri"/>
               </a:rPr>
-              <a:t>Folie 6 / 6</a:t>
+              <a:t>Folie 6 / 9</a:t>
             </a:r>
           </a:p>
         </p:txBody>
@@ -6701,7 +6701,7 @@
                 </a:solidFill>
                 <a:latin typeface="Calibri"/>
               </a:rPr>
-              <a:t>Folie 6 / 6</a:t>
+              <a:t>Folie 6 / 9</a:t>
             </a:r>
           </a:p>
         </p:txBody>
@@ -7392,7 +7392,7 @@
                 </a:solidFill>
                 <a:latin typeface="Calibri"/>
               </a:rPr>
-              <a:t>Funktionsweise</a:t>
+              <a:t>Folie 7 / 9</a:t>
             </a:r>
           </a:p>
         </p:txBody>
@@ -8743,7 +8743,7 @@
                 </a:solidFill>
                 <a:latin typeface="Calibri"/>
               </a:rPr>
-              <a:t>Bewertung</a:t>
+              <a:t>Folie 8 / 9</a:t>
             </a:r>
           </a:p>
         </p:txBody>
@@ -9680,7 +9680,7 @@
                 </a:solidFill>
                 <a:latin typeface="Calibri"/>
               </a:rPr>
-              <a:t>Roadmap</a:t>
+              <a:t>Folie 9 / 9</a:t>
             </a:r>
           </a:p>
         </p:txBody>
@@ -11573,14 +11573,49 @@
       </p:sp>
       <p:sp>
         <p:nvSpPr>
-          <p:cNvPr id="6" name="Rounded Rectangle 5"/>
+          <p:cNvPr id="6" name="TextBox 5"/>
+          <p:cNvSpPr txBox="1"/>
+          <p:nvPr/>
+        </p:nvSpPr>
+        <p:spPr>
+          <a:xfrm>
+            <a:off x="457200" y="960120"/>
+            <a:ext cx="11247120" cy="274320"/>
+          </a:xfrm>
+          <a:prstGeom prst="rect">
+            <a:avLst/>
+          </a:prstGeom>
+          <a:noFill/>
+        </p:spPr>
+        <p:txBody>
+          <a:bodyPr wrap="square" lIns="45720" rIns="45720" tIns="18288" bIns="18288" anchor="t">
+            <a:spAutoFit/>
+          </a:bodyPr>
+          <a:lstStyle/>
+          <a:p>
+            <a:pPr algn="l"/>
+            <a:r>
+              <a:rPr sz="1200" b="0" i="1">
+                <a:solidFill>
+                  <a:srgbClr val="6E7A8C"/>
+                </a:solidFill>
+                <a:latin typeface="Calibri"/>
+              </a:rPr>
+              <a:t>9 Themen · ca. 12–14 Minuten</a:t>
+            </a:r>
+          </a:p>
+        </p:txBody>
+      </p:sp>
+      <p:sp>
+        <p:nvSpPr>
+          <p:cNvPr id="7" name="Rounded Rectangle 6"/>
           <p:cNvSpPr/>
           <p:nvPr/>
         </p:nvSpPr>
         <p:spPr>
           <a:xfrm>
-            <a:off x="457200" y="1234440"/>
-            <a:ext cx="5394960" cy="1417320"/>
+            <a:off x="312267" y="1234440"/>
+            <a:ext cx="3703320" cy="1417320"/>
           </a:xfrm>
           <a:prstGeom prst="roundRect">
             <a:avLst>
@@ -11619,14 +11654,14 @@
       </p:sp>
       <p:sp>
         <p:nvSpPr>
-          <p:cNvPr id="7" name="Rectangle 6"/>
+          <p:cNvPr id="8" name="Rectangle 7"/>
           <p:cNvSpPr/>
           <p:nvPr/>
         </p:nvSpPr>
         <p:spPr>
           <a:xfrm>
-            <a:off x="457200" y="1234440"/>
-            <a:ext cx="164592" cy="1417320"/>
+            <a:off x="312267" y="1234440"/>
+            <a:ext cx="137160" cy="1417320"/>
           </a:xfrm>
           <a:prstGeom prst="rect">
             <a:avLst/>
@@ -11663,14 +11698,14 @@
       </p:sp>
       <p:sp>
         <p:nvSpPr>
-          <p:cNvPr id="8" name="TextBox 7"/>
+          <p:cNvPr id="9" name="TextBox 8"/>
           <p:cNvSpPr txBox="1"/>
           <p:nvPr/>
         </p:nvSpPr>
         <p:spPr>
           <a:xfrm>
-            <a:off x="868680" y="1325880"/>
-            <a:ext cx="1097280" cy="731520"/>
+            <a:off x="586587" y="1371600"/>
+            <a:ext cx="914400" cy="640080"/>
           </a:xfrm>
           <a:prstGeom prst="rect">
             <a:avLst/>
@@ -11685,7 +11720,7 @@
           <a:p>
             <a:pPr algn="l"/>
             <a:r>
-              <a:rPr sz="4200" b="1" i="0">
+              <a:rPr sz="3200" b="1" i="0">
                 <a:solidFill>
                   <a:srgbClr val="00C2A8"/>
                 </a:solidFill>
@@ -11698,14 +11733,14 @@
       </p:sp>
       <p:sp>
         <p:nvSpPr>
-          <p:cNvPr id="9" name="TextBox 8"/>
+          <p:cNvPr id="10" name="TextBox 9"/>
           <p:cNvSpPr txBox="1"/>
           <p:nvPr/>
         </p:nvSpPr>
         <p:spPr>
           <a:xfrm>
-            <a:off x="2011680" y="1417320"/>
-            <a:ext cx="3749040" cy="1051560"/>
+            <a:off x="1546707" y="1417320"/>
+            <a:ext cx="2377440" cy="1051560"/>
           </a:xfrm>
           <a:prstGeom prst="rect">
             <a:avLst/>
@@ -11720,7 +11755,7 @@
           <a:p>
             <a:pPr algn="l"/>
             <a:r>
-              <a:rPr sz="1800" b="1" i="0">
+              <a:rPr sz="1400" b="1" i="0">
                 <a:solidFill>
                   <a:srgbClr val="1B263A"/>
                 </a:solidFill>
@@ -11733,14 +11768,14 @@
       </p:sp>
       <p:sp>
         <p:nvSpPr>
-          <p:cNvPr id="10" name="Rounded Rectangle 9"/>
+          <p:cNvPr id="11" name="Rounded Rectangle 10"/>
           <p:cNvSpPr/>
           <p:nvPr/>
         </p:nvSpPr>
         <p:spPr>
           <a:xfrm>
-            <a:off x="6172200" y="1234440"/>
-            <a:ext cx="5394960" cy="1417320"/>
+            <a:off x="4244187" y="1234440"/>
+            <a:ext cx="3703320" cy="1417320"/>
           </a:xfrm>
           <a:prstGeom prst="roundRect">
             <a:avLst>
@@ -11779,14 +11814,14 @@
       </p:sp>
       <p:sp>
         <p:nvSpPr>
-          <p:cNvPr id="11" name="Rectangle 10"/>
+          <p:cNvPr id="12" name="Rectangle 11"/>
           <p:cNvSpPr/>
           <p:nvPr/>
         </p:nvSpPr>
         <p:spPr>
           <a:xfrm>
-            <a:off x="6172200" y="1234440"/>
-            <a:ext cx="164592" cy="1417320"/>
+            <a:off x="4244187" y="1234440"/>
+            <a:ext cx="137160" cy="1417320"/>
           </a:xfrm>
           <a:prstGeom prst="rect">
             <a:avLst/>
@@ -11823,14 +11858,14 @@
       </p:sp>
       <p:sp>
         <p:nvSpPr>
-          <p:cNvPr id="12" name="TextBox 11"/>
+          <p:cNvPr id="13" name="TextBox 12"/>
           <p:cNvSpPr txBox="1"/>
           <p:nvPr/>
         </p:nvSpPr>
         <p:spPr>
           <a:xfrm>
-            <a:off x="6583680" y="1325880"/>
-            <a:ext cx="1097280" cy="731520"/>
+            <a:off x="4518507" y="1371600"/>
+            <a:ext cx="914400" cy="640080"/>
           </a:xfrm>
           <a:prstGeom prst="rect">
             <a:avLst/>
@@ -11845,7 +11880,7 @@
           <a:p>
             <a:pPr algn="l"/>
             <a:r>
-              <a:rPr sz="4200" b="1" i="0">
+              <a:rPr sz="3200" b="1" i="0">
                 <a:solidFill>
                   <a:srgbClr val="00C2A8"/>
                 </a:solidFill>
@@ -11858,14 +11893,14 @@
       </p:sp>
       <p:sp>
         <p:nvSpPr>
-          <p:cNvPr id="13" name="TextBox 12"/>
+          <p:cNvPr id="14" name="TextBox 13"/>
           <p:cNvSpPr txBox="1"/>
           <p:nvPr/>
         </p:nvSpPr>
         <p:spPr>
           <a:xfrm>
-            <a:off x="7726680" y="1417320"/>
-            <a:ext cx="3749040" cy="1051560"/>
+            <a:off x="5478627" y="1417320"/>
+            <a:ext cx="2377440" cy="1051560"/>
           </a:xfrm>
           <a:prstGeom prst="rect">
             <a:avLst/>
@@ -11880,7 +11915,7 @@
           <a:p>
             <a:pPr algn="l"/>
             <a:r>
-              <a:rPr sz="1800" b="1" i="0">
+              <a:rPr sz="1400" b="1" i="0">
                 <a:solidFill>
                   <a:srgbClr val="1B263A"/>
                 </a:solidFill>
@@ -11893,14 +11928,14 @@
       </p:sp>
       <p:sp>
         <p:nvSpPr>
-          <p:cNvPr id="14" name="Rounded Rectangle 13"/>
+          <p:cNvPr id="15" name="Rounded Rectangle 14"/>
           <p:cNvSpPr/>
           <p:nvPr/>
         </p:nvSpPr>
         <p:spPr>
           <a:xfrm>
-            <a:off x="457200" y="2880360"/>
-            <a:ext cx="5394960" cy="1417320"/>
+            <a:off x="8176107" y="1234440"/>
+            <a:ext cx="3703320" cy="1417320"/>
           </a:xfrm>
           <a:prstGeom prst="roundRect">
             <a:avLst>
@@ -11939,14 +11974,14 @@
       </p:sp>
       <p:sp>
         <p:nvSpPr>
-          <p:cNvPr id="15" name="Rectangle 14"/>
+          <p:cNvPr id="16" name="Rectangle 15"/>
           <p:cNvSpPr/>
           <p:nvPr/>
         </p:nvSpPr>
         <p:spPr>
           <a:xfrm>
-            <a:off x="457200" y="2880360"/>
-            <a:ext cx="164592" cy="1417320"/>
+            <a:off x="8176107" y="1234440"/>
+            <a:ext cx="137160" cy="1417320"/>
           </a:xfrm>
           <a:prstGeom prst="rect">
             <a:avLst/>
@@ -11983,14 +12018,14 @@
       </p:sp>
       <p:sp>
         <p:nvSpPr>
-          <p:cNvPr id="16" name="TextBox 15"/>
+          <p:cNvPr id="17" name="TextBox 16"/>
           <p:cNvSpPr txBox="1"/>
           <p:nvPr/>
         </p:nvSpPr>
         <p:spPr>
           <a:xfrm>
-            <a:off x="868680" y="2971800"/>
-            <a:ext cx="1097280" cy="731520"/>
+            <a:off x="8450427" y="1371600"/>
+            <a:ext cx="914400" cy="640080"/>
           </a:xfrm>
           <a:prstGeom prst="rect">
             <a:avLst/>
@@ -12005,7 +12040,7 @@
           <a:p>
             <a:pPr algn="l"/>
             <a:r>
-              <a:rPr sz="4200" b="1" i="0">
+              <a:rPr sz="3200" b="1" i="0">
                 <a:solidFill>
                   <a:srgbClr val="00C2A8"/>
                 </a:solidFill>
@@ -12018,14 +12053,14 @@
       </p:sp>
       <p:sp>
         <p:nvSpPr>
-          <p:cNvPr id="17" name="TextBox 16"/>
+          <p:cNvPr id="18" name="TextBox 17"/>
           <p:cNvSpPr txBox="1"/>
           <p:nvPr/>
         </p:nvSpPr>
         <p:spPr>
           <a:xfrm>
-            <a:off x="2011680" y="3063240"/>
-            <a:ext cx="3749040" cy="1051560"/>
+            <a:off x="9410547" y="1417320"/>
+            <a:ext cx="2377440" cy="1051560"/>
           </a:xfrm>
           <a:prstGeom prst="rect">
             <a:avLst/>
@@ -12040,7 +12075,7 @@
           <a:p>
             <a:pPr algn="l"/>
             <a:r>
-              <a:rPr sz="1800" b="1" i="0">
+              <a:rPr sz="1400" b="1" i="0">
                 <a:solidFill>
                   <a:srgbClr val="1B263A"/>
                 </a:solidFill>
@@ -12053,14 +12088,14 @@
       </p:sp>
       <p:sp>
         <p:nvSpPr>
-          <p:cNvPr id="18" name="Rounded Rectangle 17"/>
+          <p:cNvPr id="19" name="Rounded Rectangle 18"/>
           <p:cNvSpPr/>
           <p:nvPr/>
         </p:nvSpPr>
         <p:spPr>
           <a:xfrm>
-            <a:off x="6172200" y="2880360"/>
-            <a:ext cx="5394960" cy="1417320"/>
+            <a:off x="312267" y="2852928"/>
+            <a:ext cx="3703320" cy="1417320"/>
           </a:xfrm>
           <a:prstGeom prst="roundRect">
             <a:avLst>
@@ -12099,14 +12134,14 @@
       </p:sp>
       <p:sp>
         <p:nvSpPr>
-          <p:cNvPr id="19" name="Rectangle 18"/>
+          <p:cNvPr id="20" name="Rectangle 19"/>
           <p:cNvSpPr/>
           <p:nvPr/>
         </p:nvSpPr>
         <p:spPr>
           <a:xfrm>
-            <a:off x="6172200" y="2880360"/>
-            <a:ext cx="164592" cy="1417320"/>
+            <a:off x="312267" y="2852928"/>
+            <a:ext cx="137160" cy="1417320"/>
           </a:xfrm>
           <a:prstGeom prst="rect">
             <a:avLst/>
@@ -12143,14 +12178,14 @@
       </p:sp>
       <p:sp>
         <p:nvSpPr>
-          <p:cNvPr id="20" name="TextBox 19"/>
+          <p:cNvPr id="21" name="TextBox 20"/>
           <p:cNvSpPr txBox="1"/>
           <p:nvPr/>
         </p:nvSpPr>
         <p:spPr>
           <a:xfrm>
-            <a:off x="6583680" y="2971800"/>
-            <a:ext cx="1097280" cy="731520"/>
+            <a:off x="586587" y="2990088"/>
+            <a:ext cx="914400" cy="640080"/>
           </a:xfrm>
           <a:prstGeom prst="rect">
             <a:avLst/>
@@ -12165,7 +12200,7 @@
           <a:p>
             <a:pPr algn="l"/>
             <a:r>
-              <a:rPr sz="4200" b="1" i="0">
+              <a:rPr sz="3200" b="1" i="0">
                 <a:solidFill>
                   <a:srgbClr val="00C2A8"/>
                 </a:solidFill>
@@ -12178,14 +12213,14 @@
       </p:sp>
       <p:sp>
         <p:nvSpPr>
-          <p:cNvPr id="21" name="TextBox 20"/>
+          <p:cNvPr id="22" name="TextBox 21"/>
           <p:cNvSpPr txBox="1"/>
           <p:nvPr/>
         </p:nvSpPr>
         <p:spPr>
           <a:xfrm>
-            <a:off x="7726680" y="3063240"/>
-            <a:ext cx="3749040" cy="1051560"/>
+            <a:off x="1546707" y="3035808"/>
+            <a:ext cx="2377440" cy="1051560"/>
           </a:xfrm>
           <a:prstGeom prst="rect">
             <a:avLst/>
@@ -12200,7 +12235,7 @@
           <a:p>
             <a:pPr algn="l"/>
             <a:r>
-              <a:rPr sz="1800" b="1" i="0">
+              <a:rPr sz="1400" b="1" i="0">
                 <a:solidFill>
                   <a:srgbClr val="1B263A"/>
                 </a:solidFill>
@@ -12213,14 +12248,14 @@
       </p:sp>
       <p:sp>
         <p:nvSpPr>
-          <p:cNvPr id="22" name="Rounded Rectangle 21"/>
+          <p:cNvPr id="23" name="Rounded Rectangle 22"/>
           <p:cNvSpPr/>
           <p:nvPr/>
         </p:nvSpPr>
         <p:spPr>
           <a:xfrm>
-            <a:off x="457200" y="4526280"/>
-            <a:ext cx="5394960" cy="1417320"/>
+            <a:off x="4244187" y="2852928"/>
+            <a:ext cx="3703320" cy="1417320"/>
           </a:xfrm>
           <a:prstGeom prst="roundRect">
             <a:avLst>
@@ -12259,14 +12294,14 @@
       </p:sp>
       <p:sp>
         <p:nvSpPr>
-          <p:cNvPr id="23" name="Rectangle 22"/>
+          <p:cNvPr id="24" name="Rectangle 23"/>
           <p:cNvSpPr/>
           <p:nvPr/>
         </p:nvSpPr>
         <p:spPr>
           <a:xfrm>
-            <a:off x="457200" y="4526280"/>
-            <a:ext cx="164592" cy="1417320"/>
+            <a:off x="4244187" y="2852928"/>
+            <a:ext cx="137160" cy="1417320"/>
           </a:xfrm>
           <a:prstGeom prst="rect">
             <a:avLst/>
@@ -12303,14 +12338,14 @@
       </p:sp>
       <p:sp>
         <p:nvSpPr>
-          <p:cNvPr id="24" name="TextBox 23"/>
+          <p:cNvPr id="25" name="TextBox 24"/>
           <p:cNvSpPr txBox="1"/>
           <p:nvPr/>
         </p:nvSpPr>
         <p:spPr>
           <a:xfrm>
-            <a:off x="868680" y="4617720"/>
-            <a:ext cx="1097280" cy="731520"/>
+            <a:off x="4518507" y="2990088"/>
+            <a:ext cx="914400" cy="640080"/>
           </a:xfrm>
           <a:prstGeom prst="rect">
             <a:avLst/>
@@ -12325,7 +12360,7 @@
           <a:p>
             <a:pPr algn="l"/>
             <a:r>
-              <a:rPr sz="4200" b="1" i="0">
+              <a:rPr sz="3200" b="1" i="0">
                 <a:solidFill>
                   <a:srgbClr val="00C2A8"/>
                 </a:solidFill>
@@ -12338,14 +12373,14 @@
       </p:sp>
       <p:sp>
         <p:nvSpPr>
-          <p:cNvPr id="25" name="TextBox 24"/>
+          <p:cNvPr id="26" name="TextBox 25"/>
           <p:cNvSpPr txBox="1"/>
           <p:nvPr/>
         </p:nvSpPr>
         <p:spPr>
           <a:xfrm>
-            <a:off x="2011680" y="4709160"/>
-            <a:ext cx="3749040" cy="1051560"/>
+            <a:off x="5478627" y="3035808"/>
+            <a:ext cx="2377440" cy="1051560"/>
           </a:xfrm>
           <a:prstGeom prst="rect">
             <a:avLst/>
@@ -12360,7 +12395,7 @@
           <a:p>
             <a:pPr algn="l"/>
             <a:r>
-              <a:rPr sz="1800" b="1" i="0">
+              <a:rPr sz="1400" b="1" i="0">
                 <a:solidFill>
                   <a:srgbClr val="1B263A"/>
                 </a:solidFill>
@@ -12373,14 +12408,14 @@
       </p:sp>
       <p:sp>
         <p:nvSpPr>
-          <p:cNvPr id="26" name="Rounded Rectangle 25"/>
+          <p:cNvPr id="27" name="Rounded Rectangle 26"/>
           <p:cNvSpPr/>
           <p:nvPr/>
         </p:nvSpPr>
         <p:spPr>
           <a:xfrm>
-            <a:off x="6172200" y="4526280"/>
-            <a:ext cx="5394960" cy="1417320"/>
+            <a:off x="8176107" y="2852928"/>
+            <a:ext cx="3703320" cy="1417320"/>
           </a:xfrm>
           <a:prstGeom prst="roundRect">
             <a:avLst>
@@ -12419,14 +12454,14 @@
       </p:sp>
       <p:sp>
         <p:nvSpPr>
-          <p:cNvPr id="27" name="Rectangle 26"/>
+          <p:cNvPr id="28" name="Rectangle 27"/>
           <p:cNvSpPr/>
           <p:nvPr/>
         </p:nvSpPr>
         <p:spPr>
           <a:xfrm>
-            <a:off x="6172200" y="4526280"/>
-            <a:ext cx="164592" cy="1417320"/>
+            <a:off x="8176107" y="2852928"/>
+            <a:ext cx="137160" cy="1417320"/>
           </a:xfrm>
           <a:prstGeom prst="rect">
             <a:avLst/>
@@ -12463,14 +12498,14 @@
       </p:sp>
       <p:sp>
         <p:nvSpPr>
-          <p:cNvPr id="28" name="TextBox 27"/>
+          <p:cNvPr id="29" name="TextBox 28"/>
           <p:cNvSpPr txBox="1"/>
           <p:nvPr/>
         </p:nvSpPr>
         <p:spPr>
           <a:xfrm>
-            <a:off x="6583680" y="4617720"/>
-            <a:ext cx="1097280" cy="731520"/>
+            <a:off x="8450427" y="2990088"/>
+            <a:ext cx="914400" cy="640080"/>
           </a:xfrm>
           <a:prstGeom prst="rect">
             <a:avLst/>
@@ -12485,7 +12520,7 @@
           <a:p>
             <a:pPr algn="l"/>
             <a:r>
-              <a:rPr sz="4200" b="1" i="0">
+              <a:rPr sz="3200" b="1" i="0">
                 <a:solidFill>
                   <a:srgbClr val="00C2A8"/>
                 </a:solidFill>
@@ -12498,14 +12533,14 @@
       </p:sp>
       <p:sp>
         <p:nvSpPr>
-          <p:cNvPr id="29" name="TextBox 28"/>
+          <p:cNvPr id="30" name="TextBox 29"/>
           <p:cNvSpPr txBox="1"/>
           <p:nvPr/>
         </p:nvSpPr>
         <p:spPr>
           <a:xfrm>
-            <a:off x="7726680" y="4709160"/>
-            <a:ext cx="3749040" cy="1051560"/>
+            <a:off x="9410547" y="3035808"/>
+            <a:ext cx="2377440" cy="1051560"/>
           </a:xfrm>
           <a:prstGeom prst="rect">
             <a:avLst/>
@@ -12520,7 +12555,7 @@
           <a:p>
             <a:pPr algn="l"/>
             <a:r>
-              <a:rPr sz="1800" b="1" i="0">
+              <a:rPr sz="1400" b="1" i="0">
                 <a:solidFill>
                   <a:srgbClr val="1B263A"/>
                 </a:solidFill>
@@ -12533,20 +12568,22 @@
       </p:sp>
       <p:sp>
         <p:nvSpPr>
-          <p:cNvPr id="30" name="Rectangle 29"/>
+          <p:cNvPr id="31" name="Rounded Rectangle 30"/>
           <p:cNvSpPr/>
           <p:nvPr/>
         </p:nvSpPr>
         <p:spPr>
           <a:xfrm>
-            <a:off x="0" y="6537960"/>
-            <a:ext cx="12191695" cy="320040"/>
-          </a:xfrm>
-          <a:prstGeom prst="rect">
-            <a:avLst/>
-          </a:prstGeom>
-          <a:solidFill>
-            <a:srgbClr val="07142E"/>
+            <a:off x="312267" y="4471416"/>
+            <a:ext cx="3703320" cy="1417320"/>
+          </a:xfrm>
+          <a:prstGeom prst="roundRect">
+            <a:avLst>
+              <a:gd name="adj" fmla="val 8000"/>
+            </a:avLst>
+          </a:prstGeom>
+          <a:solidFill>
+            <a:srgbClr val="FFFFFF"/>
           </a:solidFill>
           <a:ln>
             <a:noFill/>
@@ -12577,7 +12614,485 @@
       </p:sp>
       <p:sp>
         <p:nvSpPr>
-          <p:cNvPr id="31" name="TextBox 30"/>
+          <p:cNvPr id="32" name="Rectangle 31"/>
+          <p:cNvSpPr/>
+          <p:nvPr/>
+        </p:nvSpPr>
+        <p:spPr>
+          <a:xfrm>
+            <a:off x="312267" y="4471416"/>
+            <a:ext cx="137160" cy="1417320"/>
+          </a:xfrm>
+          <a:prstGeom prst="rect">
+            <a:avLst/>
+          </a:prstGeom>
+          <a:solidFill>
+            <a:srgbClr val="00C2A8"/>
+          </a:solidFill>
+          <a:ln>
+            <a:noFill/>
+          </a:ln>
+          <a:effectLst/>
+        </p:spPr>
+        <p:style>
+          <a:lnRef idx="1">
+            <a:schemeClr val="accent1"/>
+          </a:lnRef>
+          <a:fillRef idx="3">
+            <a:schemeClr val="accent1"/>
+          </a:fillRef>
+          <a:effectRef idx="2">
+            <a:schemeClr val="accent1"/>
+          </a:effectRef>
+          <a:fontRef idx="minor">
+            <a:schemeClr val="lt1"/>
+          </a:fontRef>
+        </p:style>
+        <p:txBody>
+          <a:bodyPr rtlCol="0" anchor="ctr"/>
+          <a:lstStyle/>
+          <a:p>
+            <a:pPr algn="ctr"/>
+          </a:p>
+        </p:txBody>
+      </p:sp>
+      <p:sp>
+        <p:nvSpPr>
+          <p:cNvPr id="33" name="TextBox 32"/>
+          <p:cNvSpPr txBox="1"/>
+          <p:nvPr/>
+        </p:nvSpPr>
+        <p:spPr>
+          <a:xfrm>
+            <a:off x="586587" y="4608576"/>
+            <a:ext cx="914400" cy="640080"/>
+          </a:xfrm>
+          <a:prstGeom prst="rect">
+            <a:avLst/>
+          </a:prstGeom>
+          <a:noFill/>
+        </p:spPr>
+        <p:txBody>
+          <a:bodyPr wrap="square" lIns="45720" rIns="45720" tIns="18288" bIns="18288" anchor="ctr">
+            <a:spAutoFit/>
+          </a:bodyPr>
+          <a:lstStyle/>
+          <a:p>
+            <a:pPr algn="l"/>
+            <a:r>
+              <a:rPr sz="3200" b="1" i="0">
+                <a:solidFill>
+                  <a:srgbClr val="00C2A8"/>
+                </a:solidFill>
+                <a:latin typeface="Calibri"/>
+              </a:rPr>
+              <a:t>07</a:t>
+            </a:r>
+          </a:p>
+        </p:txBody>
+      </p:sp>
+      <p:sp>
+        <p:nvSpPr>
+          <p:cNvPr id="34" name="TextBox 33"/>
+          <p:cNvSpPr txBox="1"/>
+          <p:nvPr/>
+        </p:nvSpPr>
+        <p:spPr>
+          <a:xfrm>
+            <a:off x="1546707" y="4654296"/>
+            <a:ext cx="2377440" cy="1051560"/>
+          </a:xfrm>
+          <a:prstGeom prst="rect">
+            <a:avLst/>
+          </a:prstGeom>
+          <a:noFill/>
+        </p:spPr>
+        <p:txBody>
+          <a:bodyPr wrap="square" lIns="45720" rIns="45720" tIns="18288" bIns="18288" anchor="ctr">
+            <a:spAutoFit/>
+          </a:bodyPr>
+          <a:lstStyle/>
+          <a:p>
+            <a:pPr algn="l"/>
+            <a:r>
+              <a:rPr sz="1400" b="1" i="0">
+                <a:solidFill>
+                  <a:srgbClr val="1B263A"/>
+                </a:solidFill>
+                <a:latin typeface="Calibri"/>
+              </a:rPr>
+              <a:t>Wie funktioniert KI-Steuerprüfung?</a:t>
+            </a:r>
+          </a:p>
+        </p:txBody>
+      </p:sp>
+      <p:sp>
+        <p:nvSpPr>
+          <p:cNvPr id="35" name="Rounded Rectangle 34"/>
+          <p:cNvSpPr/>
+          <p:nvPr/>
+        </p:nvSpPr>
+        <p:spPr>
+          <a:xfrm>
+            <a:off x="4244187" y="4471416"/>
+            <a:ext cx="3703320" cy="1417320"/>
+          </a:xfrm>
+          <a:prstGeom prst="roundRect">
+            <a:avLst>
+              <a:gd name="adj" fmla="val 8000"/>
+            </a:avLst>
+          </a:prstGeom>
+          <a:solidFill>
+            <a:srgbClr val="FFFFFF"/>
+          </a:solidFill>
+          <a:ln>
+            <a:noFill/>
+          </a:ln>
+          <a:effectLst/>
+        </p:spPr>
+        <p:style>
+          <a:lnRef idx="1">
+            <a:schemeClr val="accent1"/>
+          </a:lnRef>
+          <a:fillRef idx="3">
+            <a:schemeClr val="accent1"/>
+          </a:fillRef>
+          <a:effectRef idx="2">
+            <a:schemeClr val="accent1"/>
+          </a:effectRef>
+          <a:fontRef idx="minor">
+            <a:schemeClr val="lt1"/>
+          </a:fontRef>
+        </p:style>
+        <p:txBody>
+          <a:bodyPr rtlCol="0" anchor="ctr"/>
+          <a:lstStyle/>
+          <a:p>
+            <a:pPr algn="ctr"/>
+          </a:p>
+        </p:txBody>
+      </p:sp>
+      <p:sp>
+        <p:nvSpPr>
+          <p:cNvPr id="36" name="Rectangle 35"/>
+          <p:cNvSpPr/>
+          <p:nvPr/>
+        </p:nvSpPr>
+        <p:spPr>
+          <a:xfrm>
+            <a:off x="4244187" y="4471416"/>
+            <a:ext cx="137160" cy="1417320"/>
+          </a:xfrm>
+          <a:prstGeom prst="rect">
+            <a:avLst/>
+          </a:prstGeom>
+          <a:solidFill>
+            <a:srgbClr val="00C2A8"/>
+          </a:solidFill>
+          <a:ln>
+            <a:noFill/>
+          </a:ln>
+          <a:effectLst/>
+        </p:spPr>
+        <p:style>
+          <a:lnRef idx="1">
+            <a:schemeClr val="accent1"/>
+          </a:lnRef>
+          <a:fillRef idx="3">
+            <a:schemeClr val="accent1"/>
+          </a:fillRef>
+          <a:effectRef idx="2">
+            <a:schemeClr val="accent1"/>
+          </a:effectRef>
+          <a:fontRef idx="minor">
+            <a:schemeClr val="lt1"/>
+          </a:fontRef>
+        </p:style>
+        <p:txBody>
+          <a:bodyPr rtlCol="0" anchor="ctr"/>
+          <a:lstStyle/>
+          <a:p>
+            <a:pPr algn="ctr"/>
+          </a:p>
+        </p:txBody>
+      </p:sp>
+      <p:sp>
+        <p:nvSpPr>
+          <p:cNvPr id="37" name="TextBox 36"/>
+          <p:cNvSpPr txBox="1"/>
+          <p:nvPr/>
+        </p:nvSpPr>
+        <p:spPr>
+          <a:xfrm>
+            <a:off x="4518507" y="4608576"/>
+            <a:ext cx="914400" cy="640080"/>
+          </a:xfrm>
+          <a:prstGeom prst="rect">
+            <a:avLst/>
+          </a:prstGeom>
+          <a:noFill/>
+        </p:spPr>
+        <p:txBody>
+          <a:bodyPr wrap="square" lIns="45720" rIns="45720" tIns="18288" bIns="18288" anchor="ctr">
+            <a:spAutoFit/>
+          </a:bodyPr>
+          <a:lstStyle/>
+          <a:p>
+            <a:pPr algn="l"/>
+            <a:r>
+              <a:rPr sz="3200" b="1" i="0">
+                <a:solidFill>
+                  <a:srgbClr val="00C2A8"/>
+                </a:solidFill>
+                <a:latin typeface="Calibri"/>
+              </a:rPr>
+              <a:t>08</a:t>
+            </a:r>
+          </a:p>
+        </p:txBody>
+      </p:sp>
+      <p:sp>
+        <p:nvSpPr>
+          <p:cNvPr id="38" name="TextBox 37"/>
+          <p:cNvSpPr txBox="1"/>
+          <p:nvPr/>
+        </p:nvSpPr>
+        <p:spPr>
+          <a:xfrm>
+            <a:off x="5478627" y="4654296"/>
+            <a:ext cx="2377440" cy="1051560"/>
+          </a:xfrm>
+          <a:prstGeom prst="rect">
+            <a:avLst/>
+          </a:prstGeom>
+          <a:noFill/>
+        </p:spPr>
+        <p:txBody>
+          <a:bodyPr wrap="square" lIns="45720" rIns="45720" tIns="18288" bIns="18288" anchor="ctr">
+            <a:spAutoFit/>
+          </a:bodyPr>
+          <a:lstStyle/>
+          <a:p>
+            <a:pPr algn="l"/>
+            <a:r>
+              <a:rPr sz="1400" b="1" i="0">
+                <a:solidFill>
+                  <a:srgbClr val="1B263A"/>
+                </a:solidFill>
+                <a:latin typeface="Calibri"/>
+              </a:rPr>
+              <a:t>Chancen &amp; Risiken des KI-Einsatzes</a:t>
+            </a:r>
+          </a:p>
+        </p:txBody>
+      </p:sp>
+      <p:sp>
+        <p:nvSpPr>
+          <p:cNvPr id="39" name="Rounded Rectangle 38"/>
+          <p:cNvSpPr/>
+          <p:nvPr/>
+        </p:nvSpPr>
+        <p:spPr>
+          <a:xfrm>
+            <a:off x="8176107" y="4471416"/>
+            <a:ext cx="3703320" cy="1417320"/>
+          </a:xfrm>
+          <a:prstGeom prst="roundRect">
+            <a:avLst>
+              <a:gd name="adj" fmla="val 8000"/>
+            </a:avLst>
+          </a:prstGeom>
+          <a:solidFill>
+            <a:srgbClr val="FFFFFF"/>
+          </a:solidFill>
+          <a:ln>
+            <a:noFill/>
+          </a:ln>
+          <a:effectLst/>
+        </p:spPr>
+        <p:style>
+          <a:lnRef idx="1">
+            <a:schemeClr val="accent1"/>
+          </a:lnRef>
+          <a:fillRef idx="3">
+            <a:schemeClr val="accent1"/>
+          </a:fillRef>
+          <a:effectRef idx="2">
+            <a:schemeClr val="accent1"/>
+          </a:effectRef>
+          <a:fontRef idx="minor">
+            <a:schemeClr val="lt1"/>
+          </a:fontRef>
+        </p:style>
+        <p:txBody>
+          <a:bodyPr rtlCol="0" anchor="ctr"/>
+          <a:lstStyle/>
+          <a:p>
+            <a:pPr algn="ctr"/>
+          </a:p>
+        </p:txBody>
+      </p:sp>
+      <p:sp>
+        <p:nvSpPr>
+          <p:cNvPr id="40" name="Rectangle 39"/>
+          <p:cNvSpPr/>
+          <p:nvPr/>
+        </p:nvSpPr>
+        <p:spPr>
+          <a:xfrm>
+            <a:off x="8176107" y="4471416"/>
+            <a:ext cx="137160" cy="1417320"/>
+          </a:xfrm>
+          <a:prstGeom prst="rect">
+            <a:avLst/>
+          </a:prstGeom>
+          <a:solidFill>
+            <a:srgbClr val="00C2A8"/>
+          </a:solidFill>
+          <a:ln>
+            <a:noFill/>
+          </a:ln>
+          <a:effectLst/>
+        </p:spPr>
+        <p:style>
+          <a:lnRef idx="1">
+            <a:schemeClr val="accent1"/>
+          </a:lnRef>
+          <a:fillRef idx="3">
+            <a:schemeClr val="accent1"/>
+          </a:fillRef>
+          <a:effectRef idx="2">
+            <a:schemeClr val="accent1"/>
+          </a:effectRef>
+          <a:fontRef idx="minor">
+            <a:schemeClr val="lt1"/>
+          </a:fontRef>
+        </p:style>
+        <p:txBody>
+          <a:bodyPr rtlCol="0" anchor="ctr"/>
+          <a:lstStyle/>
+          <a:p>
+            <a:pPr algn="ctr"/>
+          </a:p>
+        </p:txBody>
+      </p:sp>
+      <p:sp>
+        <p:nvSpPr>
+          <p:cNvPr id="41" name="TextBox 40"/>
+          <p:cNvSpPr txBox="1"/>
+          <p:nvPr/>
+        </p:nvSpPr>
+        <p:spPr>
+          <a:xfrm>
+            <a:off x="8450427" y="4608576"/>
+            <a:ext cx="914400" cy="640080"/>
+          </a:xfrm>
+          <a:prstGeom prst="rect">
+            <a:avLst/>
+          </a:prstGeom>
+          <a:noFill/>
+        </p:spPr>
+        <p:txBody>
+          <a:bodyPr wrap="square" lIns="45720" rIns="45720" tIns="18288" bIns="18288" anchor="ctr">
+            <a:spAutoFit/>
+          </a:bodyPr>
+          <a:lstStyle/>
+          <a:p>
+            <a:pPr algn="l"/>
+            <a:r>
+              <a:rPr sz="3200" b="1" i="0">
+                <a:solidFill>
+                  <a:srgbClr val="00C2A8"/>
+                </a:solidFill>
+                <a:latin typeface="Calibri"/>
+              </a:rPr>
+              <a:t>09</a:t>
+            </a:r>
+          </a:p>
+        </p:txBody>
+      </p:sp>
+      <p:sp>
+        <p:nvSpPr>
+          <p:cNvPr id="42" name="TextBox 41"/>
+          <p:cNvSpPr txBox="1"/>
+          <p:nvPr/>
+        </p:nvSpPr>
+        <p:spPr>
+          <a:xfrm>
+            <a:off x="9410547" y="4654296"/>
+            <a:ext cx="2377440" cy="1051560"/>
+          </a:xfrm>
+          <a:prstGeom prst="rect">
+            <a:avLst/>
+          </a:prstGeom>
+          <a:noFill/>
+        </p:spPr>
+        <p:txBody>
+          <a:bodyPr wrap="square" lIns="45720" rIns="45720" tIns="18288" bIns="18288" anchor="ctr">
+            <a:spAutoFit/>
+          </a:bodyPr>
+          <a:lstStyle/>
+          <a:p>
+            <a:pPr algn="l"/>
+            <a:r>
+              <a:rPr sz="1400" b="1" i="0">
+                <a:solidFill>
+                  <a:srgbClr val="1B263A"/>
+                </a:solidFill>
+                <a:latin typeface="Calibri"/>
+              </a:rPr>
+              <a:t>Ausblick – 2026 und danach</a:t>
+            </a:r>
+          </a:p>
+        </p:txBody>
+      </p:sp>
+      <p:sp>
+        <p:nvSpPr>
+          <p:cNvPr id="43" name="Rectangle 42"/>
+          <p:cNvSpPr/>
+          <p:nvPr/>
+        </p:nvSpPr>
+        <p:spPr>
+          <a:xfrm>
+            <a:off x="0" y="6537960"/>
+            <a:ext cx="12191695" cy="320040"/>
+          </a:xfrm>
+          <a:prstGeom prst="rect">
+            <a:avLst/>
+          </a:prstGeom>
+          <a:solidFill>
+            <a:srgbClr val="07142E"/>
+          </a:solidFill>
+          <a:ln>
+            <a:noFill/>
+          </a:ln>
+          <a:effectLst/>
+        </p:spPr>
+        <p:style>
+          <a:lnRef idx="1">
+            <a:schemeClr val="accent1"/>
+          </a:lnRef>
+          <a:fillRef idx="3">
+            <a:schemeClr val="accent1"/>
+          </a:fillRef>
+          <a:effectRef idx="2">
+            <a:schemeClr val="accent1"/>
+          </a:effectRef>
+          <a:fontRef idx="minor">
+            <a:schemeClr val="lt1"/>
+          </a:fontRef>
+        </p:style>
+        <p:txBody>
+          <a:bodyPr rtlCol="0" anchor="ctr"/>
+          <a:lstStyle/>
+          <a:p>
+            <a:pPr algn="ctr"/>
+          </a:p>
+        </p:txBody>
+      </p:sp>
+      <p:sp>
+        <p:nvSpPr>
+          <p:cNvPr id="44" name="TextBox 43"/>
           <p:cNvSpPr txBox="1"/>
           <p:nvPr/>
         </p:nvSpPr>
@@ -12612,7 +13127,7 @@
       </p:sp>
       <p:sp>
         <p:nvSpPr>
-          <p:cNvPr id="32" name="TextBox 31"/>
+          <p:cNvPr id="45" name="TextBox 44"/>
           <p:cNvSpPr txBox="1"/>
           <p:nvPr/>
         </p:nvSpPr>
@@ -14487,7 +15002,7 @@
                 </a:solidFill>
                 <a:latin typeface="Calibri"/>
               </a:rPr>
-              <a:t>Folie 1 / 6</a:t>
+              <a:t>Folie 1 / 9</a:t>
             </a:r>
           </a:p>
         </p:txBody>
@@ -15369,7 +15884,7 @@
                 </a:solidFill>
                 <a:latin typeface="Calibri"/>
               </a:rPr>
-              <a:t>Folie 2 / 6</a:t>
+              <a:t>Folie 2 / 9</a:t>
             </a:r>
           </a:p>
         </p:txBody>
@@ -16262,7 +16777,7 @@
                 </a:solidFill>
                 <a:latin typeface="Calibri"/>
               </a:rPr>
-              <a:t>Folie 3 / 6</a:t>
+              <a:t>Folie 3 / 9</a:t>
             </a:r>
           </a:p>
         </p:txBody>
@@ -17155,7 +17670,7 @@
                 </a:solidFill>
                 <a:latin typeface="Calibri"/>
               </a:rPr>
-              <a:t>Folie 4 / 6</a:t>
+              <a:t>Folie 4 / 9</a:t>
             </a:r>
           </a:p>
         </p:txBody>
@@ -18048,7 +18563,7 @@
                 </a:solidFill>
                 <a:latin typeface="Calibri"/>
               </a:rPr>
-              <a:t>Folie 5 / 6</a:t>
+              <a:t>Folie 5 / 9</a:t>
             </a:r>
           </a:p>
         </p:txBody>
@@ -19196,7 +19711,7 @@
                 </a:solidFill>
                 <a:latin typeface="Calibri"/>
               </a:rPr>
-              <a:t>Folie 5 / 6</a:t>
+              <a:t>Folie 5 / 9</a:t>
             </a:r>
           </a:p>
         </p:txBody>
@@ -19738,7 +20253,7 @@
                 </a:solidFill>
                 <a:latin typeface="Calibri"/>
               </a:rPr>
-              <a:t>Folie 5 / 6</a:t>
+              <a:t>Folie 5 / 9</a:t>
             </a:r>
           </a:p>
         </p:txBody>

</xml_diff>